<commit_message>
chore: remove dead code and update PACT presentation files for clarity
</commit_message>
<xml_diff>
--- a/hackathon-deck/PACT_Deck.pptx
+++ b/hackathon-deck/PACT_Deck.pptx
@@ -1758,7 +1758,7 @@
                 <a:ea typeface="Segoe UI" panose="020B0502040204020203" pitchFamily="34" charset="-122"/>
                 <a:cs typeface="Segoe UI" panose="020B0502040204020203" pitchFamily="34" charset="-120"/>
               </a:rPr>
-              <a:t>A runtime security layer for AI agents. Every tool call passes a signed gateway that verifies identity, intent, capability, provenance and policy — before it runs.</a:t>
+              <a:t>A runtime security layer for AI agents. Every tool call passes a signed gateway that verifies identity, intent, capability, provenance and policy before it runs.</a:t>
             </a:r>
             <a:endParaRPr lang="en-US" sz="1450" dirty="0"/>
           </a:p>
@@ -2380,7 +2380,7 @@
                 <a:ea typeface="Segoe UI" panose="020B0502040204020203" pitchFamily="34" charset="-122"/>
                 <a:cs typeface="Segoe UI" panose="020B0502040204020203" pitchFamily="34" charset="-120"/>
               </a:rPr>
-              <a:t>Securing the agentic future — one verified action at a time.</a:t>
+              <a:t>Securing the agentic future - PACT</a:t>
             </a:r>
             <a:endParaRPr lang="en-US" sz="1600" dirty="0"/>
           </a:p>
@@ -2760,7 +2760,7 @@
                 <a:ea typeface="Segoe UI" panose="020B0502040204020203" pitchFamily="34" charset="-122"/>
                 <a:cs typeface="Segoe UI" panose="020B0502040204020203" pitchFamily="34" charset="-120"/>
               </a:rPr>
-              <a:t>Autonomous agents browse the web, read mail, and call tools on their own — so untrusted content can quietly hijack them. And traditional auth only ever checks the caller's identity, never whether a given action is legitimate.</a:t>
+              <a:t>Autonomous agents browse the web, read mail, and call tools on their own; so untrusted content can quietly hijack them. And traditional auth only ever checks the caller's identity, never whether a given action is legitimate.</a:t>
             </a:r>
             <a:endParaRPr lang="en-US" sz="1350" dirty="0"/>
           </a:p>
@@ -3315,7 +3315,7 @@
                 <a:ea typeface="Segoe UI" panose="020B0502040204020203" pitchFamily="34" charset="-122"/>
                 <a:cs typeface="Segoe UI" panose="020B0502040204020203" pitchFamily="34" charset="-120"/>
               </a:rPr>
-              <a:t>The agent reads secrets — .env, API keys — and tries to push them to an external sink.</a:t>
+              <a:t>The agent reads secrets like .env, API keys and tries to push them to an external sink.</a:t>
             </a:r>
             <a:endParaRPr lang="en-US" sz="1050" dirty="0"/>
           </a:p>
@@ -3710,7 +3710,7 @@
                 <a:ea typeface="Segoe UI" panose="020B0502040204020203" pitchFamily="34" charset="-122"/>
                 <a:cs typeface="Segoe UI" panose="020B0502040204020203" pitchFamily="34" charset="-120"/>
               </a:rPr>
-              <a:t> — and was it influenced by untrusted or secret data?”  </a:t>
+              <a:t> and was it influenced by untrusted or secret data?”  </a:t>
             </a:r>
             <a:r>
               <a:rPr lang="en-US" sz="1550" b="1" dirty="0">
@@ -3930,7 +3930,7 @@
                 <a:ea typeface="Segoe UI" panose="020B0502040204020203" pitchFamily="34" charset="-122"/>
                 <a:cs typeface="Segoe UI" panose="020B0502040204020203" pitchFamily="34" charset="-120"/>
               </a:rPr>
-              <a:t>Verify every action — not just the caller</a:t>
+              <a:t>Verify every action NOT just the caller</a:t>
             </a:r>
             <a:endParaRPr lang="en-US" sz="3000" dirty="0"/>
           </a:p>
@@ -3971,7 +3971,7 @@
                 <a:ea typeface="Segoe UI" panose="020B0502040204020203" pitchFamily="34" charset="-122"/>
                 <a:cs typeface="Segoe UI" panose="020B0502040204020203" pitchFamily="34" charset="-120"/>
               </a:rPr>
-              <a:t>An agent cannot call tools directly. It must wrap each call in a signed Action Envelope and submit it to the Gateway — the single trust boundary in the system.</a:t>
+              <a:t>An agent cannot call tools directly. It must wrap each call in a signed Action Envelope and submit it to the Gateway the single trust boundary in the system.</a:t>
             </a:r>
             <a:endParaRPr lang="en-US" sz="1450" dirty="0"/>
           </a:p>
@@ -4355,7 +4355,7 @@
                 <a:ea typeface="Segoe UI" panose="020B0502040204020203" pitchFamily="34" charset="-122"/>
                 <a:cs typeface="Segoe UI" panose="020B0502040204020203" pitchFamily="34" charset="-120"/>
               </a:rPr>
-              <a:t>Blocks by authority and data-flow — not by pattern-matching bad strings or filtering prompts.</a:t>
+              <a:t>Blocks by authority and data-flow not by pattern-matching</a:t>
             </a:r>
             <a:endParaRPr lang="en-US" sz="1150" dirty="0"/>
           </a:p>
@@ -4717,7 +4717,7 @@
                 <a:ea typeface="Segoe UI" panose="020B0502040204020203" pitchFamily="34" charset="-122"/>
                 <a:cs typeface="Segoe UI" panose="020B0502040204020203" pitchFamily="34" charset="-120"/>
               </a:rPr>
-              <a:t>Shell exec or a critical secret read — a human is put in the loop.</a:t>
+              <a:t>Shell exec or a critical secret read, a human is put in the loop.</a:t>
             </a:r>
             <a:endParaRPr lang="en-US" sz="1100" dirty="0"/>
           </a:p>
@@ -8536,7 +8536,34 @@
                 <a:ea typeface="Segoe UI" panose="020B0502040204020203" pitchFamily="34" charset="-122"/>
                 <a:cs typeface="Segoe UI" panose="020B0502040204020203" pitchFamily="34" charset="-120"/>
               </a:rPr>
-              <a:t>real gateway HTTP clients — sign their own envelopes locally</a:t>
+              <a:t>real gateway HTTP clients</a:t>
+            </a:r>
+            <a:endParaRPr lang="en-US" sz="1050" dirty="0">
+              <a:solidFill>
+                <a:srgbClr val="9FB3C8"/>
+              </a:solidFill>
+              <a:latin typeface="Segoe UI" panose="020B0502040204020203" pitchFamily="34" charset="0"/>
+              <a:ea typeface="Segoe UI" panose="020B0502040204020203" pitchFamily="34" charset="-122"/>
+              <a:cs typeface="Segoe UI" panose="020B0502040204020203" pitchFamily="34" charset="-120"/>
+            </a:endParaRPr>
+          </a:p>
+          <a:p>
+            <a:pPr marL="0" indent="0">
+              <a:lnSpc>
+                <a:spcPct val="108000"/>
+              </a:lnSpc>
+              <a:buNone/>
+            </a:pPr>
+            <a:r>
+              <a:rPr lang="en-US" sz="1050" dirty="0">
+                <a:solidFill>
+                  <a:srgbClr val="9FB3C8"/>
+                </a:solidFill>
+                <a:latin typeface="Segoe UI" panose="020B0502040204020203" pitchFamily="34" charset="0"/>
+                <a:ea typeface="Segoe UI" panose="020B0502040204020203" pitchFamily="34" charset="-122"/>
+                <a:cs typeface="Segoe UI" panose="020B0502040204020203" pitchFamily="34" charset="-120"/>
+              </a:rPr>
+              <a:t>sign their own envelopes locally</a:t>
             </a:r>
             <a:endParaRPr lang="en-US" sz="1050" dirty="0"/>
           </a:p>
@@ -9218,7 +9245,7 @@
                 <a:ea typeface="Segoe UI" panose="020B0502040204020203" pitchFamily="34" charset="-122"/>
                 <a:cs typeface="Segoe UI" panose="020B0502040204020203" pitchFamily="34" charset="-120"/>
               </a:rPr>
-              <a:t>The LLM picks tools to satisfy the user's goal — and every call it makes is wrapped in a signed envelope first.</a:t>
+              <a:t>The LLM picks tools to satisfy the user's goal and every call it makes is wrapped in a signed envelope first.</a:t>
             </a:r>
             <a:endParaRPr lang="en-US" sz="1100" dirty="0"/>
           </a:p>
@@ -9508,7 +9535,29 @@
                 <a:ea typeface="Segoe UI" panose="020B0502040204020203" pitchFamily="34" charset="-122"/>
                 <a:cs typeface="Segoe UI" panose="020B0502040204020203" pitchFamily="34" charset="-120"/>
               </a:rPr>
-              <a:t>Policy decisions are made by deterministic rules (R1–R12) plus risk scoring — never by a model.</a:t>
+              <a:t>Policy decisions are made by deterministic rules (R1–R12) plus risk scoring, </a:t>
+            </a:r>
+            <a:r>
+              <a:rPr lang="en-US" sz="1300" b="1" dirty="0">
+                <a:solidFill>
+                  <a:srgbClr val="E6EDF6"/>
+                </a:solidFill>
+                <a:latin typeface="Segoe UI" panose="020B0502040204020203" pitchFamily="34" charset="0"/>
+                <a:ea typeface="Segoe UI" panose="020B0502040204020203" pitchFamily="34" charset="-122"/>
+                <a:cs typeface="Segoe UI" panose="020B0502040204020203" pitchFamily="34" charset="-120"/>
+              </a:rPr>
+              <a:t>NEVER </a:t>
+            </a:r>
+            <a:r>
+              <a:rPr lang="en-US" sz="1300" dirty="0">
+                <a:solidFill>
+                  <a:srgbClr val="E6EDF6"/>
+                </a:solidFill>
+                <a:latin typeface="Segoe UI" panose="020B0502040204020203" pitchFamily="34" charset="0"/>
+                <a:ea typeface="Segoe UI" panose="020B0502040204020203" pitchFamily="34" charset="-122"/>
+                <a:cs typeface="Segoe UI" panose="020B0502040204020203" pitchFamily="34" charset="-120"/>
+              </a:rPr>
+              <a:t>by a model.</a:t>
             </a:r>
             <a:endParaRPr lang="en-US" sz="1300" dirty="0"/>
           </a:p>
@@ -11298,7 +11347,7 @@
                 <a:ea typeface="Segoe UI" panose="020B0502040204020203" pitchFamily="34" charset="-122"/>
                 <a:cs typeface="Segoe UI" panose="020B0502040204020203" pitchFamily="34" charset="-120"/>
               </a:rPr>
-              <a:t>Rename the file or change the address — still blocked. The boundaries don't depend on the strings.</a:t>
+              <a:t>Rename the file or change the address still blocked. The boundaries don't depend on the strings.</a:t>
             </a:r>
             <a:endParaRPr lang="en-US" sz="1050" dirty="0"/>
           </a:p>
@@ -14173,7 +14222,7 @@
                 <a:ea typeface="Segoe UI" panose="020B0502040204020203" pitchFamily="34" charset="-122"/>
                 <a:cs typeface="Segoe UI" panose="020B0502040204020203" pitchFamily="34" charset="-120"/>
               </a:rPr>
-              <a:t>Built to be verifiable — and to ship</a:t>
+              <a:t>Built to be verifiable and to ship</a:t>
             </a:r>
             <a:endParaRPr lang="en-US" sz="3000" dirty="0"/>
           </a:p>
@@ -14920,7 +14969,7 @@
                 <a:ea typeface="Segoe UI" panose="020B0502040204020203" pitchFamily="34" charset="-122"/>
                 <a:cs typeface="Segoe UI" panose="020B0502040204020203" pitchFamily="34" charset="-120"/>
               </a:rPr>
-              <a:t>Go · Bubble Tea · Lipgloss — a full-screen TUI client of the gateway</a:t>
+              <a:t>Go · Bubble Tea · Lipgloss, a full-screen TUI client of the gateway</a:t>
             </a:r>
             <a:endParaRPr lang="en-US" sz="1050" dirty="0"/>
           </a:p>
@@ -15041,7 +15090,7 @@
                 <a:ea typeface="Segoe UI" panose="020B0502040204020203" pitchFamily="34" charset="-122"/>
                 <a:cs typeface="Segoe UI" panose="020B0502040204020203" pitchFamily="34" charset="-120"/>
               </a:rPr>
-              <a:t>v0.0.1</a:t>
+              <a:t>v0.0.2</a:t>
             </a:r>
             <a:endParaRPr lang="en-US" sz="2000" dirty="0"/>
           </a:p>

</xml_diff>